<commit_message>
Usubscribe and deletebutton homologised
</commit_message>
<xml_diff>
--- a/C_Mail.pptx
+++ b/C_Mail.pptx
@@ -14428,47 +14428,6 @@
           </a:p>
         </p:txBody>
       </p:sp>
-      <p:cxnSp>
-        <p:nvCxnSpPr>
-          <p:cNvPr id="13" name="Gerade Verbindung mit Pfeil 12">
-            <a:extLst>
-              <a:ext uri="{FF2B5EF4-FFF2-40B4-BE49-F238E27FC236}">
-                <a16:creationId xmlns:a16="http://schemas.microsoft.com/office/drawing/2014/main" id="{2BB51266-9388-492B-B2E1-8C2A4E4AF6DC}"/>
-              </a:ext>
-            </a:extLst>
-          </p:cNvPr>
-          <p:cNvCxnSpPr>
-            <a:cxnSpLocks/>
-          </p:cNvCxnSpPr>
-          <p:nvPr/>
-        </p:nvCxnSpPr>
-        <p:spPr>
-          <a:xfrm>
-            <a:off x="6020089" y="738829"/>
-            <a:ext cx="735724" cy="0"/>
-          </a:xfrm>
-          <a:prstGeom prst="straightConnector1">
-            <a:avLst/>
-          </a:prstGeom>
-          <a:ln>
-            <a:tailEnd type="triangle"/>
-          </a:ln>
-        </p:spPr>
-        <p:style>
-          <a:lnRef idx="1">
-            <a:schemeClr val="dk1"/>
-          </a:lnRef>
-          <a:fillRef idx="0">
-            <a:schemeClr val="dk1"/>
-          </a:fillRef>
-          <a:effectRef idx="0">
-            <a:schemeClr val="dk1"/>
-          </a:effectRef>
-          <a:fontRef idx="minor">
-            <a:schemeClr val="tx1"/>
-          </a:fontRef>
-        </p:style>
-      </p:cxnSp>
       <p:pic>
         <p:nvPicPr>
           <p:cNvPr id="1026" name="Picture 2">
@@ -14642,10 +14601,10 @@
       </p:pic>
       <p:pic>
         <p:nvPicPr>
-          <p:cNvPr id="15" name="Grafik 14">
+          <p:cNvPr id="3" name="Grafik 2">
             <a:extLst>
               <a:ext uri="{FF2B5EF4-FFF2-40B4-BE49-F238E27FC236}">
-                <a16:creationId xmlns:a16="http://schemas.microsoft.com/office/drawing/2014/main" id="{99B1CC63-BFB8-4BA7-86CD-30FFEF6153C6}"/>
+                <a16:creationId xmlns:a16="http://schemas.microsoft.com/office/drawing/2014/main" id="{780C696B-742C-4344-85D3-CBD6035C80B1}"/>
               </a:ext>
             </a:extLst>
           </p:cNvPr>
@@ -14662,14 +14621,83 @@
         </p:blipFill>
         <p:spPr>
           <a:xfrm>
-            <a:off x="7429356" y="4734480"/>
-            <a:ext cx="3231051" cy="1817466"/>
+            <a:off x="7507303" y="3001934"/>
+            <a:ext cx="3153104" cy="1773621"/>
           </a:xfrm>
           <a:prstGeom prst="rect">
             <a:avLst/>
           </a:prstGeom>
         </p:spPr>
       </p:pic>
+      <p:pic>
+        <p:nvPicPr>
+          <p:cNvPr id="16" name="Grafik 15">
+            <a:extLst>
+              <a:ext uri="{FF2B5EF4-FFF2-40B4-BE49-F238E27FC236}">
+                <a16:creationId xmlns:a16="http://schemas.microsoft.com/office/drawing/2014/main" id="{F4E9EFF6-3992-4FD1-8719-9E021AF30E31}"/>
+              </a:ext>
+            </a:extLst>
+          </p:cNvPr>
+          <p:cNvPicPr>
+            <a:picLocks noChangeAspect="1"/>
+          </p:cNvPicPr>
+          <p:nvPr/>
+        </p:nvPicPr>
+        <p:blipFill>
+          <a:blip r:embed="rId8"/>
+          <a:stretch>
+            <a:fillRect/>
+          </a:stretch>
+        </p:blipFill>
+        <p:spPr>
+          <a:xfrm>
+            <a:off x="7509779" y="4769413"/>
+            <a:ext cx="3150628" cy="1772228"/>
+          </a:xfrm>
+          <a:prstGeom prst="rect">
+            <a:avLst/>
+          </a:prstGeom>
+        </p:spPr>
+      </p:pic>
+      <p:cxnSp>
+        <p:nvCxnSpPr>
+          <p:cNvPr id="21" name="Gerade Verbindung mit Pfeil 20">
+            <a:extLst>
+              <a:ext uri="{FF2B5EF4-FFF2-40B4-BE49-F238E27FC236}">
+                <a16:creationId xmlns:a16="http://schemas.microsoft.com/office/drawing/2014/main" id="{A9260E54-4ED0-4193-B72A-E25BC7E3451A}"/>
+              </a:ext>
+            </a:extLst>
+          </p:cNvPr>
+          <p:cNvCxnSpPr/>
+          <p:nvPr/>
+        </p:nvCxnSpPr>
+        <p:spPr>
+          <a:xfrm>
+            <a:off x="5724939" y="3429000"/>
+            <a:ext cx="1341783" cy="0"/>
+          </a:xfrm>
+          <a:prstGeom prst="straightConnector1">
+            <a:avLst/>
+          </a:prstGeom>
+          <a:ln>
+            <a:tailEnd type="triangle"/>
+          </a:ln>
+        </p:spPr>
+        <p:style>
+          <a:lnRef idx="1">
+            <a:schemeClr val="dk1"/>
+          </a:lnRef>
+          <a:fillRef idx="0">
+            <a:schemeClr val="dk1"/>
+          </a:fillRef>
+          <a:effectRef idx="0">
+            <a:schemeClr val="dk1"/>
+          </a:effectRef>
+          <a:fontRef idx="minor">
+            <a:schemeClr val="tx1"/>
+          </a:fontRef>
+        </p:style>
+      </p:cxnSp>
     </p:spTree>
     <p:extLst>
       <p:ext uri="{BB962C8B-B14F-4D97-AF65-F5344CB8AC3E}">

</xml_diff>